<commit_message>
Add second member and split contributions evenly
</commit_message>
<xml_diff>
--- a/Matcha_CS13_LanhDao.pptx
+++ b/Matcha_CS13_LanhDao.pptx
@@ -2,13 +2,13 @@
 <file path=ppt/presentation.xml><?xml version="1.0" encoding="utf-8"?>
 <p:presentation xmlns:p="http://schemas.openxmlformats.org/presentationml/2006/main">
   <p:sldMasterIdLst>
-    <p:sldMasterId xmlns:r="http://schemas.openxmlformats.org/officeDocument/2006/relationships" id="2147483648" r:id="Rcb34fbedae1d4328"/>
+    <p:sldMasterId xmlns:r="http://schemas.openxmlformats.org/officeDocument/2006/relationships" id="2147483648" r:id="Rd8017ed44a7e4ec0"/>
   </p:sldMasterIdLst>
   <p:notesMasterIdLst>
-    <p:notesMasterId xmlns:r="http://schemas.openxmlformats.org/officeDocument/2006/relationships" r:id="R93bcc12a6cd74d75"/>
+    <p:notesMasterId xmlns:r="http://schemas.openxmlformats.org/officeDocument/2006/relationships" r:id="R9902b64bf28341a7"/>
   </p:notesMasterIdLst>
   <p:sldIdLst>
-    <p:sldId xmlns:r="http://schemas.openxmlformats.org/officeDocument/2006/relationships" id="256" r:id="R0af21101e9984244"/>
+    <p:sldId xmlns:r="http://schemas.openxmlformats.org/officeDocument/2006/relationships" id="256" r:id="Rf5add8f998b74ac5"/>
   </p:sldIdLst>
   <p:sldSz cx="12192000" cy="6858000"/>
   <p:notesSz cx="6858000" cy="9144000"/>
@@ -485,7 +485,7 @@
           <p:cNvPr id="3" name="Title">
             <a:extLst xmlns:a="http://schemas.openxmlformats.org/drawingml/2006/main">
               <a:ext uri="{FF2B5EF4-FFF2-40B4-BE49-F238E27FC236}">
-                <a16:creationId xmlns:a16="http://schemas.microsoft.com/office/drawing/2014/main" id="{26E9FCB9-0E63-4581-BA2A-97AD9C8D9CCE}"/>
+                <a16:creationId xmlns:a16="http://schemas.microsoft.com/office/drawing/2014/main" id="{1D0CA97D-08A8-4FCE-9E3D-A2FF35096F12}"/>
               </a:ext>
             </a:extLst>
           </p:cNvPr>
@@ -642,7 +642,7 @@
           <p:cNvPr id="2" name="Subtitle">
             <a:extLst xmlns:a="http://schemas.openxmlformats.org/drawingml/2006/main">
               <a:ext uri="{FF2B5EF4-FFF2-40B4-BE49-F238E27FC236}">
-                <a16:creationId xmlns:a16="http://schemas.microsoft.com/office/drawing/2014/main" id="{F074991D-B599-40D5-A7D7-AB7D594FA5B6}"/>
+                <a16:creationId xmlns:a16="http://schemas.microsoft.com/office/drawing/2014/main" id="{CD60D641-63AB-493C-98F9-3AA555011DF8}"/>
               </a:ext>
             </a:extLst>
           </p:cNvPr>
@@ -816,7 +816,7 @@
           <p:cNvPr id="2" name="Section title">
             <a:extLst xmlns:a="http://schemas.openxmlformats.org/drawingml/2006/main">
               <a:ext uri="{FF2B5EF4-FFF2-40B4-BE49-F238E27FC236}">
-                <a16:creationId xmlns:a16="http://schemas.microsoft.com/office/drawing/2014/main" id="{A6A28C7A-1FBA-4C6F-AF1B-3AC93A6CB271}"/>
+                <a16:creationId xmlns:a16="http://schemas.microsoft.com/office/drawing/2014/main" id="{CD0E13E3-A2D1-4189-B3C4-72D5B24672C8}"/>
               </a:ext>
             </a:extLst>
           </p:cNvPr>
@@ -990,7 +990,7 @@
           <p:cNvPr id="3" name="Title">
             <a:extLst xmlns:a="http://schemas.openxmlformats.org/drawingml/2006/main">
               <a:ext uri="{FF2B5EF4-FFF2-40B4-BE49-F238E27FC236}">
-                <a16:creationId xmlns:a16="http://schemas.microsoft.com/office/drawing/2014/main" id="{E944EAAA-0E9E-4129-8CA3-D85647FA82FE}"/>
+                <a16:creationId xmlns:a16="http://schemas.microsoft.com/office/drawing/2014/main" id="{03E4B732-F7FE-497A-9C26-3B2CBDF1191C}"/>
               </a:ext>
             </a:extLst>
           </p:cNvPr>
@@ -1147,7 +1147,7 @@
           <p:cNvPr id="2" name="Body">
             <a:extLst xmlns:a="http://schemas.openxmlformats.org/drawingml/2006/main">
               <a:ext uri="{FF2B5EF4-FFF2-40B4-BE49-F238E27FC236}">
-                <a16:creationId xmlns:a16="http://schemas.microsoft.com/office/drawing/2014/main" id="{357C774A-4067-4617-A0EE-90324B3ED230}"/>
+                <a16:creationId xmlns:a16="http://schemas.microsoft.com/office/drawing/2014/main" id="{652FA15A-CA39-4275-B89E-5851F10C93F5}"/>
               </a:ext>
             </a:extLst>
           </p:cNvPr>
@@ -1321,7 +1321,7 @@
           <p:cNvPr id="4" name="Title">
             <a:extLst xmlns:a="http://schemas.openxmlformats.org/drawingml/2006/main">
               <a:ext uri="{FF2B5EF4-FFF2-40B4-BE49-F238E27FC236}">
-                <a16:creationId xmlns:a16="http://schemas.microsoft.com/office/drawing/2014/main" id="{75641340-D243-490E-8686-545A85D76FED}"/>
+                <a16:creationId xmlns:a16="http://schemas.microsoft.com/office/drawing/2014/main" id="{60B37774-F7E5-4213-83BE-AC808D8D1DEA}"/>
               </a:ext>
             </a:extLst>
           </p:cNvPr>
@@ -1478,7 +1478,7 @@
           <p:cNvPr id="2" name="Left column">
             <a:extLst xmlns:a="http://schemas.openxmlformats.org/drawingml/2006/main">
               <a:ext uri="{FF2B5EF4-FFF2-40B4-BE49-F238E27FC236}">
-                <a16:creationId xmlns:a16="http://schemas.microsoft.com/office/drawing/2014/main" id="{17ED546C-8D30-4E1D-9079-3EE7FF8BA4A8}"/>
+                <a16:creationId xmlns:a16="http://schemas.microsoft.com/office/drawing/2014/main" id="{DF6CD094-CB72-4572-AE4C-15352DF6A93F}"/>
               </a:ext>
             </a:extLst>
           </p:cNvPr>
@@ -1635,7 +1635,7 @@
           <p:cNvPr id="3" name="Right column">
             <a:extLst xmlns:a="http://schemas.openxmlformats.org/drawingml/2006/main">
               <a:ext uri="{FF2B5EF4-FFF2-40B4-BE49-F238E27FC236}">
-                <a16:creationId xmlns:a16="http://schemas.microsoft.com/office/drawing/2014/main" id="{90D8A972-96B1-4A40-AAA6-B02BF555E306}"/>
+                <a16:creationId xmlns:a16="http://schemas.microsoft.com/office/drawing/2014/main" id="{B709B887-56CA-454F-A7EF-45A7DF17C604}"/>
               </a:ext>
             </a:extLst>
           </p:cNvPr>
@@ -1809,7 +1809,7 @@
           <p:cNvPr id="3" name="Title">
             <a:extLst xmlns:a="http://schemas.openxmlformats.org/drawingml/2006/main">
               <a:ext uri="{FF2B5EF4-FFF2-40B4-BE49-F238E27FC236}">
-                <a16:creationId xmlns:a16="http://schemas.microsoft.com/office/drawing/2014/main" id="{97637EE1-0B93-4602-945F-4CE9E3BC61DE}"/>
+                <a16:creationId xmlns:a16="http://schemas.microsoft.com/office/drawing/2014/main" id="{27683E3D-292A-4913-BCC8-41C2F73A4ED1}"/>
               </a:ext>
             </a:extLst>
           </p:cNvPr>
@@ -1966,7 +1966,7 @@
           <p:cNvPr id="2" name="Left column">
             <a:extLst xmlns:a="http://schemas.openxmlformats.org/drawingml/2006/main">
               <a:ext uri="{FF2B5EF4-FFF2-40B4-BE49-F238E27FC236}">
-                <a16:creationId xmlns:a16="http://schemas.microsoft.com/office/drawing/2014/main" id="{CF39B38E-4CCA-4C4B-8A9D-5A3C6E8D1E1D}"/>
+                <a16:creationId xmlns:a16="http://schemas.microsoft.com/office/drawing/2014/main" id="{9DC0CB37-7437-47F4-87D3-58A33CA3AB90}"/>
               </a:ext>
             </a:extLst>
           </p:cNvPr>
@@ -2161,12 +2161,12 @@
   </p:cSld>
   <p:clrMap bg1="lt1" tx1="dk1" bg2="lt2" tx2="dk2" accent1="accent1" accent2="accent2" accent3="accent3" accent4="accent4" accent5="accent5" accent6="accent6" hlink="hlink" folHlink="folHlink"/>
   <p:sldLayoutIdLst>
-    <p:sldLayoutId xmlns:r="http://schemas.openxmlformats.org/officeDocument/2006/relationships" id="2147483649" r:id="R8d775c8e1ae44684"/>
-    <p:sldLayoutId xmlns:r="http://schemas.openxmlformats.org/officeDocument/2006/relationships" id="2147483650" r:id="Rb8e2d56bf9954567"/>
-    <p:sldLayoutId xmlns:r="http://schemas.openxmlformats.org/officeDocument/2006/relationships" id="2147483651" r:id="Reee8ec08401842e0"/>
-    <p:sldLayoutId xmlns:r="http://schemas.openxmlformats.org/officeDocument/2006/relationships" id="2147483652" r:id="R4d3f7756c8fe40d2"/>
-    <p:sldLayoutId xmlns:r="http://schemas.openxmlformats.org/officeDocument/2006/relationships" id="2147483653" r:id="R5bc6a43eb56445f7"/>
-    <p:sldLayoutId xmlns:r="http://schemas.openxmlformats.org/officeDocument/2006/relationships" id="2147483654" r:id="R74f14352021945e6"/>
+    <p:sldLayoutId xmlns:r="http://schemas.openxmlformats.org/officeDocument/2006/relationships" id="2147483649" r:id="Rba212feaa4084650"/>
+    <p:sldLayoutId xmlns:r="http://schemas.openxmlformats.org/officeDocument/2006/relationships" id="2147483650" r:id="Raf8b0f6450e34db4"/>
+    <p:sldLayoutId xmlns:r="http://schemas.openxmlformats.org/officeDocument/2006/relationships" id="2147483651" r:id="R72b263cc6cc74af2"/>
+    <p:sldLayoutId xmlns:r="http://schemas.openxmlformats.org/officeDocument/2006/relationships" id="2147483652" r:id="R4f365408b2c14cd9"/>
+    <p:sldLayoutId xmlns:r="http://schemas.openxmlformats.org/officeDocument/2006/relationships" id="2147483653" r:id="Redaa86b6059c4ba7"/>
+    <p:sldLayoutId xmlns:r="http://schemas.openxmlformats.org/officeDocument/2006/relationships" id="2147483654" r:id="R5e19909cbf0f41e5"/>
   </p:sldLayoutIdLst>
   <p:txStyles>
     <p:titleStyle>
@@ -2717,7 +2717,7 @@
           <p:cNvPr id="25" name="">
             <a:extLst xmlns:a="http://schemas.openxmlformats.org/drawingml/2006/main">
               <a:ext uri="{FF2B5EF4-FFF2-40B4-BE49-F238E27FC236}">
-                <a16:creationId xmlns:a16="http://schemas.microsoft.com/office/drawing/2014/main" id="{3A70E46F-AE44-4D30-AD83-0C63F894ED30}"/>
+                <a16:creationId xmlns:a16="http://schemas.microsoft.com/office/drawing/2014/main" id="{63989DEF-B4EE-4FD1-A096-BC9C847242BB}"/>
               </a:ext>
             </a:extLst>
           </p:cNvPr>
@@ -2729,7 +2729,7 @@
         <p:spPr>
           <a:xfrm xmlns:a="http://schemas.openxmlformats.org/drawingml/2006/main">
             <a:off x="685800" y="361950"/>
-            <a:ext cx="4953000" cy="247650"/>
+            <a:ext cx="10572750" cy="247650"/>
           </a:xfrm>
           <a:prstGeom xmlns:a="http://schemas.openxmlformats.org/drawingml/2006/main" prst="rect">
             <a:avLst/>
@@ -2744,7 +2744,7 @@
           <a:bodyPr xmlns:a="http://schemas.openxmlformats.org/drawingml/2006/main"/>
           <a:lstStyle xmlns:a="http://schemas.openxmlformats.org/drawingml/2006/main">
             <a:defPPr>
-              <a:defRPr sz="1200" b="1">
+              <a:defRPr sz="1125" b="1">
                 <a:solidFill>
                   <a:srgbClr val="4F7F56"/>
                 </a:solidFill>
@@ -2756,7 +2756,7 @@
           </a:lstStyle>
           <a:p xmlns:a="http://schemas.openxmlformats.org/drawingml/2006/main">
             <a:pPr>
-              <a:defRPr sz="1200" b="1">
+              <a:defRPr sz="1125" b="1">
                 <a:solidFill>
                   <a:srgbClr val="4F7F56"/>
                 </a:solidFill>
@@ -2766,7 +2766,7 @@
               </a:defRPr>
             </a:pPr>
             <a:r>
-              <a:rPr sz="1200" b="1">
+              <a:rPr sz="1125" b="1">
                 <a:solidFill>
                   <a:srgbClr val="4F7F56"/>
                 </a:solidFill>
@@ -2774,7 +2774,7 @@
                 <a:ea typeface="Arial"/>
                 <a:cs typeface="Arial"/>
               </a:rPr>
-              <a:t>MATCHA  /  CS13 · ĐỀ 1</a:t>
+              <a:t>MATCHA · LÊ THỊ DUYÊN &amp; NGUYỄN THÙY LINH · ĐỀ 1</a:t>
             </a:r>
           </a:p>
         </p:txBody>
@@ -2784,7 +2784,7 @@
           <p:cNvPr id="2" name="">
             <a:extLst xmlns:a="http://schemas.openxmlformats.org/drawingml/2006/main">
               <a:ext uri="{FF2B5EF4-FFF2-40B4-BE49-F238E27FC236}">
-                <a16:creationId xmlns:a16="http://schemas.microsoft.com/office/drawing/2014/main" id="{3C396039-862E-4258-93E0-BE14410AE881}"/>
+                <a16:creationId xmlns:a16="http://schemas.microsoft.com/office/drawing/2014/main" id="{179ECFC8-E30A-48EB-82B9-A62E88176313}"/>
               </a:ext>
             </a:extLst>
           </p:cNvPr>
@@ -2851,7 +2851,7 @@
           <p:cNvPr id="3" name="">
             <a:extLst xmlns:a="http://schemas.openxmlformats.org/drawingml/2006/main">
               <a:ext uri="{FF2B5EF4-FFF2-40B4-BE49-F238E27FC236}">
-                <a16:creationId xmlns:a16="http://schemas.microsoft.com/office/drawing/2014/main" id="{0F8BCCE6-6DEC-4085-9615-1CEDFD098905}"/>
+                <a16:creationId xmlns:a16="http://schemas.microsoft.com/office/drawing/2014/main" id="{BE3D1EE1-337F-4F85-BFC6-55FD828F33CF}"/>
               </a:ext>
             </a:extLst>
           </p:cNvPr>
@@ -2918,7 +2918,7 @@
           <p:cNvPr id="4" name="">
             <a:extLst xmlns:a="http://schemas.openxmlformats.org/drawingml/2006/main">
               <a:ext uri="{FF2B5EF4-FFF2-40B4-BE49-F238E27FC236}">
-                <a16:creationId xmlns:a16="http://schemas.microsoft.com/office/drawing/2014/main" id="{029B2D56-CC91-47C9-94D1-531FFA6AD4E9}"/>
+                <a16:creationId xmlns:a16="http://schemas.microsoft.com/office/drawing/2014/main" id="{8375CCA3-EAF8-4228-A515-45218263426D}"/>
               </a:ext>
             </a:extLst>
           </p:cNvPr>
@@ -2951,7 +2951,7 @@
           <p:cNvPr id="5" name="">
             <a:extLst xmlns:a="http://schemas.openxmlformats.org/drawingml/2006/main">
               <a:ext uri="{FF2B5EF4-FFF2-40B4-BE49-F238E27FC236}">
-                <a16:creationId xmlns:a16="http://schemas.microsoft.com/office/drawing/2014/main" id="{FD9C4ECE-0A68-4D13-9C0E-3FC052926486}"/>
+                <a16:creationId xmlns:a16="http://schemas.microsoft.com/office/drawing/2014/main" id="{98FE12EC-7FCA-4EAD-BB21-5BF02C076074}"/>
               </a:ext>
             </a:extLst>
           </p:cNvPr>
@@ -2984,7 +2984,7 @@
           <p:cNvPr id="6" name="">
             <a:extLst xmlns:a="http://schemas.openxmlformats.org/drawingml/2006/main">
               <a:ext uri="{FF2B5EF4-FFF2-40B4-BE49-F238E27FC236}">
-                <a16:creationId xmlns:a16="http://schemas.microsoft.com/office/drawing/2014/main" id="{6593660B-D73C-410A-B211-B19B4386E9EE}"/>
+                <a16:creationId xmlns:a16="http://schemas.microsoft.com/office/drawing/2014/main" id="{C13E0579-AE71-4BD3-8E02-1D33031CC15B}"/>
               </a:ext>
             </a:extLst>
           </p:cNvPr>
@@ -3017,7 +3017,7 @@
           <p:cNvPr id="7" name="">
             <a:extLst xmlns:a="http://schemas.openxmlformats.org/drawingml/2006/main">
               <a:ext uri="{FF2B5EF4-FFF2-40B4-BE49-F238E27FC236}">
-                <a16:creationId xmlns:a16="http://schemas.microsoft.com/office/drawing/2014/main" id="{70EED395-3FF5-4D81-B1BD-D70215D912EA}"/>
+                <a16:creationId xmlns:a16="http://schemas.microsoft.com/office/drawing/2014/main" id="{D24875E5-FEA4-4AE8-924E-4D6A45952CF3}"/>
               </a:ext>
             </a:extLst>
           </p:cNvPr>
@@ -3050,7 +3050,7 @@
           <p:cNvPr id="8" name="">
             <a:extLst xmlns:a="http://schemas.openxmlformats.org/drawingml/2006/main">
               <a:ext uri="{FF2B5EF4-FFF2-40B4-BE49-F238E27FC236}">
-                <a16:creationId xmlns:a16="http://schemas.microsoft.com/office/drawing/2014/main" id="{016668D1-7B0B-4285-8C69-B130EC3F136E}"/>
+                <a16:creationId xmlns:a16="http://schemas.microsoft.com/office/drawing/2014/main" id="{A80C658C-073D-419A-841F-88760ACC7ED3}"/>
               </a:ext>
             </a:extLst>
           </p:cNvPr>
@@ -3083,7 +3083,7 @@
           <p:cNvPr id="9" name="">
             <a:extLst xmlns:a="http://schemas.openxmlformats.org/drawingml/2006/main">
               <a:ext uri="{FF2B5EF4-FFF2-40B4-BE49-F238E27FC236}">
-                <a16:creationId xmlns:a16="http://schemas.microsoft.com/office/drawing/2014/main" id="{2B42E703-1A90-4022-971D-DC1BEFCE1213}"/>
+                <a16:creationId xmlns:a16="http://schemas.microsoft.com/office/drawing/2014/main" id="{A7D40AA5-75F3-4380-AF50-6CFF87C76FC1}"/>
               </a:ext>
             </a:extLst>
           </p:cNvPr>
@@ -3150,7 +3150,7 @@
           <p:cNvPr id="10" name="">
             <a:extLst xmlns:a="http://schemas.openxmlformats.org/drawingml/2006/main">
               <a:ext uri="{FF2B5EF4-FFF2-40B4-BE49-F238E27FC236}">
-                <a16:creationId xmlns:a16="http://schemas.microsoft.com/office/drawing/2014/main" id="{12D4D699-8368-4EA4-85E3-8A85699FA5BB}"/>
+                <a16:creationId xmlns:a16="http://schemas.microsoft.com/office/drawing/2014/main" id="{65EA304B-EC83-469B-8A86-94CF67BE57DF}"/>
               </a:ext>
             </a:extLst>
           </p:cNvPr>
@@ -3217,7 +3217,7 @@
           <p:cNvPr id="11" name="">
             <a:extLst xmlns:a="http://schemas.openxmlformats.org/drawingml/2006/main">
               <a:ext uri="{FF2B5EF4-FFF2-40B4-BE49-F238E27FC236}">
-                <a16:creationId xmlns:a16="http://schemas.microsoft.com/office/drawing/2014/main" id="{74A0ED89-D4C3-4215-BD70-F0E970BC2F69}"/>
+                <a16:creationId xmlns:a16="http://schemas.microsoft.com/office/drawing/2014/main" id="{9208F50F-B287-4084-8B03-4C085E317EA9}"/>
               </a:ext>
             </a:extLst>
           </p:cNvPr>
@@ -3284,7 +3284,7 @@
           <p:cNvPr id="12" name="">
             <a:extLst xmlns:a="http://schemas.openxmlformats.org/drawingml/2006/main">
               <a:ext uri="{FF2B5EF4-FFF2-40B4-BE49-F238E27FC236}">
-                <a16:creationId xmlns:a16="http://schemas.microsoft.com/office/drawing/2014/main" id="{D0CFC8ED-503E-4C20-9B30-4E68FE842A66}"/>
+                <a16:creationId xmlns:a16="http://schemas.microsoft.com/office/drawing/2014/main" id="{4866E504-0999-4C08-9328-B3007372127D}"/>
               </a:ext>
             </a:extLst>
           </p:cNvPr>
@@ -3351,7 +3351,7 @@
           <p:cNvPr id="13" name="">
             <a:extLst xmlns:a="http://schemas.openxmlformats.org/drawingml/2006/main">
               <a:ext uri="{FF2B5EF4-FFF2-40B4-BE49-F238E27FC236}">
-                <a16:creationId xmlns:a16="http://schemas.microsoft.com/office/drawing/2014/main" id="{B3ADC3C8-146A-42FC-9C24-BE890E532521}"/>
+                <a16:creationId xmlns:a16="http://schemas.microsoft.com/office/drawing/2014/main" id="{B6B8DFED-E0E5-4A5C-8344-239CF787EAE6}"/>
               </a:ext>
             </a:extLst>
           </p:cNvPr>
@@ -3418,7 +3418,7 @@
           <p:cNvPr id="14" name="">
             <a:extLst xmlns:a="http://schemas.openxmlformats.org/drawingml/2006/main">
               <a:ext uri="{FF2B5EF4-FFF2-40B4-BE49-F238E27FC236}">
-                <a16:creationId xmlns:a16="http://schemas.microsoft.com/office/drawing/2014/main" id="{A5B70F64-BC3E-40B4-AB4C-BCF158D3BCEA}"/>
+                <a16:creationId xmlns:a16="http://schemas.microsoft.com/office/drawing/2014/main" id="{D0BF1F83-0B27-4C74-920E-67AF551E8947}"/>
               </a:ext>
             </a:extLst>
           </p:cNvPr>
@@ -3485,7 +3485,7 @@
           <p:cNvPr id="15" name="">
             <a:extLst xmlns:a="http://schemas.openxmlformats.org/drawingml/2006/main">
               <a:ext uri="{FF2B5EF4-FFF2-40B4-BE49-F238E27FC236}">
-                <a16:creationId xmlns:a16="http://schemas.microsoft.com/office/drawing/2014/main" id="{733D54A3-0BDD-4014-B30F-9BE13A6F7A2F}"/>
+                <a16:creationId xmlns:a16="http://schemas.microsoft.com/office/drawing/2014/main" id="{F21B12B7-100C-4638-A8DB-A8F638620FBE}"/>
               </a:ext>
             </a:extLst>
           </p:cNvPr>
@@ -3552,7 +3552,7 @@
           <p:cNvPr id="16" name="">
             <a:extLst xmlns:a="http://schemas.openxmlformats.org/drawingml/2006/main">
               <a:ext uri="{FF2B5EF4-FFF2-40B4-BE49-F238E27FC236}">
-                <a16:creationId xmlns:a16="http://schemas.microsoft.com/office/drawing/2014/main" id="{C0BF17F8-944E-480A-86FE-C36613857F5B}"/>
+                <a16:creationId xmlns:a16="http://schemas.microsoft.com/office/drawing/2014/main" id="{875065A2-AA43-4209-B5E1-8192EF027EF2}"/>
               </a:ext>
             </a:extLst>
           </p:cNvPr>
@@ -3619,7 +3619,7 @@
           <p:cNvPr id="17" name="">
             <a:extLst xmlns:a="http://schemas.openxmlformats.org/drawingml/2006/main">
               <a:ext uri="{FF2B5EF4-FFF2-40B4-BE49-F238E27FC236}">
-                <a16:creationId xmlns:a16="http://schemas.microsoft.com/office/drawing/2014/main" id="{760FEBA0-73E1-4064-A9F5-D49875813FAD}"/>
+                <a16:creationId xmlns:a16="http://schemas.microsoft.com/office/drawing/2014/main" id="{CB86FAE3-145C-4F70-A437-76361E73C081}"/>
               </a:ext>
             </a:extLst>
           </p:cNvPr>
@@ -3686,7 +3686,7 @@
           <p:cNvPr id="18" name="">
             <a:extLst xmlns:a="http://schemas.openxmlformats.org/drawingml/2006/main">
               <a:ext uri="{FF2B5EF4-FFF2-40B4-BE49-F238E27FC236}">
-                <a16:creationId xmlns:a16="http://schemas.microsoft.com/office/drawing/2014/main" id="{CE5E9A78-5E66-4C01-9856-106B055251E9}"/>
+                <a16:creationId xmlns:a16="http://schemas.microsoft.com/office/drawing/2014/main" id="{15F60C1A-E17B-41DD-89A2-ABCEBCE170D2}"/>
               </a:ext>
             </a:extLst>
           </p:cNvPr>
@@ -3719,7 +3719,7 @@
           <p:cNvPr id="19" name="">
             <a:extLst xmlns:a="http://schemas.openxmlformats.org/drawingml/2006/main">
               <a:ext uri="{FF2B5EF4-FFF2-40B4-BE49-F238E27FC236}">
-                <a16:creationId xmlns:a16="http://schemas.microsoft.com/office/drawing/2014/main" id="{53AAAE4C-9933-43B8-8D7B-7C27D0E5BEB4}"/>
+                <a16:creationId xmlns:a16="http://schemas.microsoft.com/office/drawing/2014/main" id="{BDB5294B-4604-438D-BD78-BAD0399A619D}"/>
               </a:ext>
             </a:extLst>
           </p:cNvPr>
@@ -3786,7 +3786,7 @@
           <p:cNvPr id="20" name="">
             <a:extLst xmlns:a="http://schemas.openxmlformats.org/drawingml/2006/main">
               <a:ext uri="{FF2B5EF4-FFF2-40B4-BE49-F238E27FC236}">
-                <a16:creationId xmlns:a16="http://schemas.microsoft.com/office/drawing/2014/main" id="{AD6E64FF-B4C7-4B6C-B8B4-067A8835645E}"/>
+                <a16:creationId xmlns:a16="http://schemas.microsoft.com/office/drawing/2014/main" id="{DCA26009-91E4-4535-A14E-BFFDD6713084}"/>
               </a:ext>
             </a:extLst>
           </p:cNvPr>
@@ -3853,7 +3853,7 @@
           <p:cNvPr id="21" name="">
             <a:extLst xmlns:a="http://schemas.openxmlformats.org/drawingml/2006/main">
               <a:ext uri="{FF2B5EF4-FFF2-40B4-BE49-F238E27FC236}">
-                <a16:creationId xmlns:a16="http://schemas.microsoft.com/office/drawing/2014/main" id="{E49F671F-1515-4ADE-8833-568E59A56D78}"/>
+                <a16:creationId xmlns:a16="http://schemas.microsoft.com/office/drawing/2014/main" id="{56E73ED0-611C-41D6-AA0F-941767F30B79}"/>
               </a:ext>
             </a:extLst>
           </p:cNvPr>
@@ -3920,7 +3920,7 @@
           <p:cNvPr id="22" name="">
             <a:extLst xmlns:a="http://schemas.openxmlformats.org/drawingml/2006/main">
               <a:ext uri="{FF2B5EF4-FFF2-40B4-BE49-F238E27FC236}">
-                <a16:creationId xmlns:a16="http://schemas.microsoft.com/office/drawing/2014/main" id="{199D46C5-F5DD-48CF-97A6-C4F474FBDF76}"/>
+                <a16:creationId xmlns:a16="http://schemas.microsoft.com/office/drawing/2014/main" id="{A8512690-AB33-41C7-81E9-D22EFEBAB5DD}"/>
               </a:ext>
             </a:extLst>
           </p:cNvPr>
@@ -3987,7 +3987,7 @@
           <p:cNvPr id="23" name="">
             <a:extLst xmlns:a="http://schemas.openxmlformats.org/drawingml/2006/main">
               <a:ext uri="{FF2B5EF4-FFF2-40B4-BE49-F238E27FC236}">
-                <a16:creationId xmlns:a16="http://schemas.microsoft.com/office/drawing/2014/main" id="{3D37CB50-6351-4C0B-A63F-A154259F97CA}"/>
+                <a16:creationId xmlns:a16="http://schemas.microsoft.com/office/drawing/2014/main" id="{AB7B279D-367F-4695-85A2-6D0B741A7906}"/>
               </a:ext>
             </a:extLst>
           </p:cNvPr>
@@ -4020,7 +4020,7 @@
           <p:cNvPr id="24" name="">
             <a:extLst xmlns:a="http://schemas.openxmlformats.org/drawingml/2006/main">
               <a:ext uri="{FF2B5EF4-FFF2-40B4-BE49-F238E27FC236}">
-                <a16:creationId xmlns:a16="http://schemas.microsoft.com/office/drawing/2014/main" id="{15ACB186-6A3C-4518-A62A-40B6DE592A38}"/>
+                <a16:creationId xmlns:a16="http://schemas.microsoft.com/office/drawing/2014/main" id="{523F1D57-F0CD-4BCA-82D5-F9FA8F48D9F9}"/>
               </a:ext>
             </a:extLst>
           </p:cNvPr>
@@ -4085,7 +4085,7 @@
     </p:spTree>
     <p:extLst>
       <p:ext uri="{BB962C8B-B14F-4D97-AF65-F5344CB8AC3E}">
-        <p14:creationId xmlns:p14="http://schemas.microsoft.com/office/powerpoint/2010/main" val="1604892876"/>
+        <p14:creationId xmlns:p14="http://schemas.microsoft.com/office/powerpoint/2010/main" val="25748154"/>
       </p:ext>
     </p:extLst>
   </p:cSld>

</xml_diff>